<commit_message>
docs: refresh generated docs and layout corpus output
</commit_message>
<xml_diff>
--- a/docs/layout-corpus.pptx
+++ b/docs/layout-corpus.pptx
@@ -3655,6 +3655,62 @@
 </p:sldLayout>
 </file>
 
+<file path=ppt/slideLayouts/slideLayout4.xml><?xml version="1.0" encoding="utf-8"?>
+<p:sldLayout xmlns:a="http://schemas.openxmlformats.org/drawingml/2006/main" xmlns:r="http://schemas.openxmlformats.org/officeDocument/2006/relationships" xmlns:p="http://schemas.openxmlformats.org/presentationml/2006/main" preserve="1">
+  <p:cSld name="FREEPORT_EXEC_SUMMARY">
+    <p:bg>
+      <p:bgPr>
+        <a:solidFill>
+          <a:srgbClr val="FFFFFF"/>
+        </a:solidFill>
+      </p:bgPr>
+    </p:bg>
+    <p:spTree>
+      <p:nvGrpSpPr>
+        <p:cNvPr id="1" name=""/>
+        <p:cNvGrpSpPr/>
+        <p:nvPr/>
+      </p:nvGrpSpPr>
+      <p:grpSpPr>
+        <a:xfrm>
+          <a:off x="0" y="0"/>
+          <a:ext cx="0" cy="0"/>
+          <a:chOff x="0" y="0"/>
+          <a:chExt cx="0" cy="0"/>
+        </a:xfrm>
+      </p:grpSpPr>
+      <p:pic>
+        <p:nvPicPr>
+          <p:cNvPr id="2" name="Image 0" descr="/Users/catronro/Documents/Codex/v2PresBuild/assets/freeport-template/bg-executive-summary-master.png">    </p:cNvPr>
+          <p:cNvPicPr>
+            <a:picLocks noChangeAspect="1"/>
+          </p:cNvPicPr>
+          <p:nvPr/>
+        </p:nvPicPr>
+        <p:blipFill>
+          <a:blip r:embed="rId1"/>
+          <a:stretch>
+            <a:fillRect/>
+          </a:stretch>
+        </p:blipFill>
+        <p:spPr>
+          <a:xfrm>
+            <a:off x="0" y="0"/>
+            <a:ext cx="12191695" cy="6858000"/>
+          </a:xfrm>
+          <a:prstGeom prst="rect">
+            <a:avLst/>
+          </a:prstGeom>
+        </p:spPr>
+      </p:pic>
+    </p:spTree>
+  </p:cSld>
+  <p:clrMapOvr>
+    <a:masterClrMapping/>
+  </p:clrMapOvr>
+</p:sldLayout>
+</file>
+
 <file path=ppt/slideMasters/slideMaster1.xml><?xml version="1.0" encoding="utf-8"?>
 <p:sldMaster xmlns:a="http://schemas.openxmlformats.org/drawingml/2006/main" xmlns:r="http://schemas.openxmlformats.org/officeDocument/2006/relationships" xmlns:p="http://schemas.openxmlformats.org/presentationml/2006/main">
   <p:cSld>
@@ -3679,6 +3735,7 @@
     <p:sldLayoutId id="2147483649" r:id="rId1"/>
     <p:sldLayoutId id="2147483650" r:id="rId2"/>
     <p:sldLayoutId id="2147483651" r:id="rId3"/>
+    <p:sldLayoutId id="2147483652" r:id="rId4"/>
   </p:sldLayoutIdLst>
   <p:hf sldNum="0" hdr="0" ftr="0" dt="0"/>
   <p:txStyles>
@@ -6650,26 +6707,28 @@
         </p:nvSpPr>
         <p:spPr>
           <a:xfrm>
-            <a:off x="231343" y="192024"/>
-            <a:ext cx="8183880" cy="1024128"/>
-          </a:xfrm>
-          <a:prstGeom prst="rect">
-            <a:avLst/>
-          </a:prstGeom>
-          <a:noFill/>
-          <a:ln/>
-        </p:spPr>
-        <p:txBody>
-          <a:bodyPr wrap="square" lIns="0" tIns="0" rIns="0" bIns="0" rtlCol="0" anchor="t"/>
-          <a:lstStyle/>
-          <a:p>
-            <a:pPr indent="0" marL="0">
+            <a:off x="155448" y="2011680"/>
+            <a:ext cx="4069080" cy="2834640"/>
+          </a:xfrm>
+          <a:prstGeom prst="rect">
+            <a:avLst/>
+          </a:prstGeom>
+          <a:noFill/>
+          <a:ln/>
+        </p:spPr>
+        <p:txBody>
+          <a:bodyPr wrap="square" lIns="0" tIns="0" rIns="0" bIns="0" rtlCol="0" anchor="ctr">
+            <a:normAutofit/>
+          </a:bodyPr>
+          <a:lstStyle/>
+          <a:p>
+            <a:pPr algn="l" indent="0" marL="0">
               <a:buNone/>
             </a:pPr>
             <a:r>
-              <a:rPr lang="en-US" sz="2800" b="1" dirty="0">
-                <a:solidFill>
-                  <a:srgbClr val="FFFFFF"/>
+              <a:rPr lang="en-US" sz="3300" dirty="0">
+                <a:solidFill>
+                  <a:srgbClr val="000000"/>
                 </a:solidFill>
                 <a:latin typeface="Arial" pitchFamily="34" charset="0"/>
                 <a:ea typeface="Arial" pitchFamily="34" charset="-122"/>
@@ -6677,95 +6736,31 @@
               </a:rPr>
               <a:t>Layout Variation: summary_card.</a:t>
             </a:r>
-            <a:endParaRPr lang="en-US" sz="2800" dirty="0"/>
-          </a:p>
-        </p:txBody>
-      </p:sp>
-      <p:sp>
-        <p:nvSpPr>
-          <p:cNvPr id="5" name="Shape 3"/>
-          <p:cNvSpPr/>
-          <p:nvPr/>
-        </p:nvSpPr>
-        <p:spPr>
-          <a:xfrm>
-            <a:off x="609448" y="1783080"/>
-            <a:ext cx="10972800" cy="4434840"/>
-          </a:xfrm>
-          <a:prstGeom prst="roundRect">
-            <a:avLst>
-              <a:gd name="adj" fmla="val 1649"/>
-            </a:avLst>
-          </a:prstGeom>
-          <a:solidFill>
-            <a:srgbClr val="FFFFFF"/>
-          </a:solidFill>
-          <a:ln w="12700">
-            <a:solidFill>
-              <a:srgbClr val="D1D5DB"/>
-            </a:solidFill>
-            <a:prstDash val="solid"/>
-          </a:ln>
-        </p:spPr>
-      </p:sp>
-      <p:sp>
-        <p:nvSpPr>
-          <p:cNvPr id="6" name="Text 4"/>
-          <p:cNvSpPr/>
-          <p:nvPr/>
-        </p:nvSpPr>
-        <p:spPr>
-          <a:xfrm>
-            <a:off x="883768" y="2103120"/>
-            <a:ext cx="10424160" cy="1188720"/>
-          </a:xfrm>
-          <a:prstGeom prst="rect">
-            <a:avLst/>
-          </a:prstGeom>
-          <a:noFill/>
-          <a:ln/>
-        </p:spPr>
-        <p:txBody>
-          <a:bodyPr wrap="square" lIns="0" tIns="0" rIns="0" bIns="0" rtlCol="0" anchor="t"/>
-          <a:lstStyle/>
-          <a:p>
-            <a:pPr indent="0" marL="0">
-              <a:buNone/>
-            </a:pPr>
-            <a:r>
-              <a:rPr lang="en-US" sz="1800" dirty="0">
-                <a:solidFill>
-                  <a:srgbClr val="092033"/>
-                </a:solidFill>
-                <a:latin typeface="Arial" pitchFamily="34" charset="0"/>
-                <a:ea typeface="Arial" pitchFamily="34" charset="-122"/>
-                <a:cs typeface="Arial" pitchFamily="34" charset="-120"/>
-              </a:rPr>
-              <a:t>This slide demonstrates a single renderer variation for developer review.</a:t>
-            </a:r>
-            <a:endParaRPr lang="en-US" sz="1800" dirty="0"/>
-          </a:p>
-        </p:txBody>
-      </p:sp>
-      <p:sp>
-        <p:nvSpPr>
-          <p:cNvPr id="7" name="Text 5"/>
-          <p:cNvSpPr/>
-          <p:nvPr/>
-        </p:nvSpPr>
-        <p:spPr>
-          <a:xfrm>
-            <a:off x="883768" y="3429000"/>
-            <a:ext cx="10424160" cy="2651760"/>
-          </a:xfrm>
-          <a:prstGeom prst="rect">
-            <a:avLst/>
-          </a:prstGeom>
-          <a:noFill/>
-          <a:ln/>
-        </p:spPr>
-        <p:txBody>
-          <a:bodyPr wrap="square" lIns="0" tIns="0" rIns="0" bIns="0" rtlCol="0" anchor="t"/>
+            <a:endParaRPr lang="en-US" sz="3300" dirty="0"/>
+          </a:p>
+        </p:txBody>
+      </p:sp>
+      <p:sp>
+        <p:nvSpPr>
+          <p:cNvPr id="5" name="Text 3"/>
+          <p:cNvSpPr/>
+          <p:nvPr/>
+        </p:nvSpPr>
+        <p:spPr>
+          <a:xfrm>
+            <a:off x="4736592" y="1051560"/>
+            <a:ext cx="7022592" cy="1245870"/>
+          </a:xfrm>
+          <a:prstGeom prst="rect">
+            <a:avLst/>
+          </a:prstGeom>
+          <a:noFill/>
+          <a:ln/>
+        </p:spPr>
+        <p:txBody>
+          <a:bodyPr wrap="square" lIns="0" tIns="0" rIns="0" bIns="0" rtlCol="0" anchor="t">
+            <a:normAutofit/>
+          </a:bodyPr>
           <a:lstStyle/>
           <a:p>
             <a:pPr marL="228600" indent="-228600">
@@ -6773,7 +6768,7 @@
               <a:buChar char="•"/>
             </a:pPr>
             <a:r>
-              <a:rPr lang="en-US" sz="1500" dirty="0">
+              <a:rPr lang="en-US" sz="2300" dirty="0">
                 <a:solidFill>
                   <a:srgbClr val="334155"/>
                 </a:solidFill>
@@ -6783,15 +6778,39 @@
               </a:rPr>
               <a:t>Use this slide to inspect spacing, hierarchy, and readability.</a:t>
             </a:r>
-            <a:endParaRPr lang="en-US" sz="1500" dirty="0"/>
-          </a:p>
+            <a:endParaRPr lang="en-US" sz="2300" dirty="0"/>
+          </a:p>
+        </p:txBody>
+      </p:sp>
+      <p:sp>
+        <p:nvSpPr>
+          <p:cNvPr id="6" name="Text 4"/>
+          <p:cNvSpPr/>
+          <p:nvPr/>
+        </p:nvSpPr>
+        <p:spPr>
+          <a:xfrm>
+            <a:off x="4736592" y="2480310"/>
+            <a:ext cx="7022592" cy="1245870"/>
+          </a:xfrm>
+          <a:prstGeom prst="rect">
+            <a:avLst/>
+          </a:prstGeom>
+          <a:noFill/>
+          <a:ln/>
+        </p:spPr>
+        <p:txBody>
+          <a:bodyPr wrap="square" lIns="0" tIns="0" rIns="0" bIns="0" rtlCol="0" anchor="t">
+            <a:normAutofit/>
+          </a:bodyPr>
+          <a:lstStyle/>
           <a:p>
             <a:pPr marL="228600" indent="-228600">
               <a:buSzPct val="100000"/>
               <a:buChar char="•"/>
             </a:pPr>
             <a:r>
-              <a:rPr lang="en-US" sz="1500" dirty="0">
+              <a:rPr lang="en-US" sz="2300" dirty="0">
                 <a:solidFill>
                   <a:srgbClr val="334155"/>
                 </a:solidFill>
@@ -6801,15 +6820,39 @@
               </a:rPr>
               <a:t>Variation naming is reflected directly in the title.</a:t>
             </a:r>
-            <a:endParaRPr lang="en-US" sz="1500" dirty="0"/>
-          </a:p>
+            <a:endParaRPr lang="en-US" sz="2300" dirty="0"/>
+          </a:p>
+        </p:txBody>
+      </p:sp>
+      <p:sp>
+        <p:nvSpPr>
+          <p:cNvPr id="7" name="Text 5"/>
+          <p:cNvSpPr/>
+          <p:nvPr/>
+        </p:nvSpPr>
+        <p:spPr>
+          <a:xfrm>
+            <a:off x="4736592" y="3909060"/>
+            <a:ext cx="7022592" cy="1245870"/>
+          </a:xfrm>
+          <a:prstGeom prst="rect">
+            <a:avLst/>
+          </a:prstGeom>
+          <a:noFill/>
+          <a:ln/>
+        </p:spPr>
+        <p:txBody>
+          <a:bodyPr wrap="square" lIns="0" tIns="0" rIns="0" bIns="0" rtlCol="0" anchor="t">
+            <a:normAutofit/>
+          </a:bodyPr>
+          <a:lstStyle/>
           <a:p>
             <a:pPr marL="228600" indent="-228600">
               <a:buSzPct val="100000"/>
               <a:buChar char="•"/>
             </a:pPr>
             <a:r>
-              <a:rPr lang="en-US" sz="1500" dirty="0">
+              <a:rPr lang="en-US" sz="2300" dirty="0">
                 <a:solidFill>
                   <a:srgbClr val="334155"/>
                 </a:solidFill>
@@ -6819,15 +6862,39 @@
               </a:rPr>
               <a:t>Content is synthetic and designed for visual QA only.</a:t>
             </a:r>
-            <a:endParaRPr lang="en-US" sz="1500" dirty="0"/>
-          </a:p>
+            <a:endParaRPr lang="en-US" sz="2300" dirty="0"/>
+          </a:p>
+        </p:txBody>
+      </p:sp>
+      <p:sp>
+        <p:nvSpPr>
+          <p:cNvPr id="8" name="Text 6"/>
+          <p:cNvSpPr/>
+          <p:nvPr/>
+        </p:nvSpPr>
+        <p:spPr>
+          <a:xfrm>
+            <a:off x="4736592" y="5337810"/>
+            <a:ext cx="7022592" cy="1245870"/>
+          </a:xfrm>
+          <a:prstGeom prst="rect">
+            <a:avLst/>
+          </a:prstGeom>
+          <a:noFill/>
+          <a:ln/>
+        </p:spPr>
+        <p:txBody>
+          <a:bodyPr wrap="square" lIns="0" tIns="0" rIns="0" bIns="0" rtlCol="0" anchor="t">
+            <a:normAutofit/>
+          </a:bodyPr>
+          <a:lstStyle/>
           <a:p>
             <a:pPr marL="228600" indent="-228600">
               <a:buSzPct val="100000"/>
               <a:buChar char="•"/>
             </a:pPr>
             <a:r>
-              <a:rPr lang="en-US" sz="1500" dirty="0">
+              <a:rPr lang="en-US" sz="2300" dirty="0">
                 <a:solidFill>
                   <a:srgbClr val="334155"/>
                 </a:solidFill>
@@ -6837,7 +6904,7 @@
               </a:rPr>
               <a:t>Compare this slide with sibling variations of the same layout.</a:t>
             </a:r>
-            <a:endParaRPr lang="en-US" sz="1500" dirty="0"/>
+            <a:endParaRPr lang="en-US" sz="2300" dirty="0"/>
           </a:p>
         </p:txBody>
       </p:sp>
@@ -7419,12 +7486,12 @@
         </p:nvSpPr>
         <p:spPr>
           <a:xfrm>
-            <a:off x="609448" y="1783080"/>
-            <a:ext cx="10972800" cy="960120"/>
+            <a:off x="609448" y="1700784"/>
+            <a:ext cx="10972800" cy="1133856"/>
           </a:xfrm>
           <a:prstGeom prst="roundRect">
             <a:avLst>
-              <a:gd name="adj" fmla="val 7619"/>
+              <a:gd name="adj" fmla="val 6452"/>
             </a:avLst>
           </a:prstGeom>
           <a:solidFill>
@@ -7446,8 +7513,8 @@
         </p:nvSpPr>
         <p:spPr>
           <a:xfrm>
-            <a:off x="883768" y="1938528"/>
-            <a:ext cx="10424160" cy="713232"/>
+            <a:off x="883768" y="1837944"/>
+            <a:ext cx="10424160" cy="932688"/>
           </a:xfrm>
           <a:prstGeom prst="rect">
             <a:avLst/>
@@ -7485,7 +7552,7 @@
         </p:nvSpPr>
         <p:spPr>
           <a:xfrm>
-            <a:off x="609448" y="2907792"/>
+            <a:off x="609448" y="2962656"/>
             <a:ext cx="2194560" cy="1572768"/>
           </a:xfrm>
           <a:prstGeom prst="roundRect">
@@ -7512,7 +7579,7 @@
         </p:nvSpPr>
         <p:spPr>
           <a:xfrm>
-            <a:off x="792328" y="3054096"/>
+            <a:off x="792328" y="3108960"/>
             <a:ext cx="1828800" cy="256032"/>
           </a:xfrm>
           <a:prstGeom prst="rect">
@@ -7551,7 +7618,7 @@
         </p:nvSpPr>
         <p:spPr>
           <a:xfrm>
-            <a:off x="792328" y="3410712"/>
+            <a:off x="792328" y="3465576"/>
             <a:ext cx="1828800" cy="475488"/>
           </a:xfrm>
           <a:prstGeom prst="rect">
@@ -7590,7 +7657,7 @@
         </p:nvSpPr>
         <p:spPr>
           <a:xfrm>
-            <a:off x="792328" y="3931920"/>
+            <a:off x="792328" y="3986784"/>
             <a:ext cx="1828800" cy="411480"/>
           </a:xfrm>
           <a:prstGeom prst="rect">
@@ -7629,7 +7696,7 @@
         </p:nvSpPr>
         <p:spPr>
           <a:xfrm>
-            <a:off x="2986888" y="2907792"/>
+            <a:off x="2986888" y="2962656"/>
             <a:ext cx="2194560" cy="1572768"/>
           </a:xfrm>
           <a:prstGeom prst="roundRect">
@@ -7656,7 +7723,7 @@
         </p:nvSpPr>
         <p:spPr>
           <a:xfrm>
-            <a:off x="3169768" y="3054096"/>
+            <a:off x="3169768" y="3108960"/>
             <a:ext cx="1828800" cy="256032"/>
           </a:xfrm>
           <a:prstGeom prst="rect">
@@ -7695,7 +7762,7 @@
         </p:nvSpPr>
         <p:spPr>
           <a:xfrm>
-            <a:off x="3169768" y="3410712"/>
+            <a:off x="3169768" y="3465576"/>
             <a:ext cx="1828800" cy="475488"/>
           </a:xfrm>
           <a:prstGeom prst="rect">
@@ -7734,7 +7801,7 @@
         </p:nvSpPr>
         <p:spPr>
           <a:xfrm>
-            <a:off x="3169768" y="3931920"/>
+            <a:off x="3169768" y="3986784"/>
             <a:ext cx="1828800" cy="411480"/>
           </a:xfrm>
           <a:prstGeom prst="rect">
@@ -7773,7 +7840,7 @@
         </p:nvSpPr>
         <p:spPr>
           <a:xfrm>
-            <a:off x="609448" y="4663440"/>
+            <a:off x="609448" y="4718304"/>
             <a:ext cx="2194560" cy="1572768"/>
           </a:xfrm>
           <a:prstGeom prst="roundRect">
@@ -7800,7 +7867,7 @@
         </p:nvSpPr>
         <p:spPr>
           <a:xfrm>
-            <a:off x="792328" y="4809744"/>
+            <a:off x="792328" y="4864608"/>
             <a:ext cx="1828800" cy="256032"/>
           </a:xfrm>
           <a:prstGeom prst="rect">
@@ -7839,7 +7906,7 @@
         </p:nvSpPr>
         <p:spPr>
           <a:xfrm>
-            <a:off x="792328" y="5166360"/>
+            <a:off x="792328" y="5221224"/>
             <a:ext cx="1828800" cy="475488"/>
           </a:xfrm>
           <a:prstGeom prst="rect">
@@ -7878,7 +7945,7 @@
         </p:nvSpPr>
         <p:spPr>
           <a:xfrm>
-            <a:off x="792328" y="5687568"/>
+            <a:off x="792328" y="5742432"/>
             <a:ext cx="1828800" cy="411480"/>
           </a:xfrm>
           <a:prstGeom prst="rect">
@@ -7917,7 +7984,7 @@
         </p:nvSpPr>
         <p:spPr>
           <a:xfrm>
-            <a:off x="2986888" y="4663440"/>
+            <a:off x="2986888" y="4718304"/>
             <a:ext cx="2194560" cy="1572768"/>
           </a:xfrm>
           <a:prstGeom prst="roundRect">
@@ -7944,7 +8011,7 @@
         </p:nvSpPr>
         <p:spPr>
           <a:xfrm>
-            <a:off x="3169768" y="4809744"/>
+            <a:off x="3169768" y="4864608"/>
             <a:ext cx="1828800" cy="256032"/>
           </a:xfrm>
           <a:prstGeom prst="rect">
@@ -7983,7 +8050,7 @@
         </p:nvSpPr>
         <p:spPr>
           <a:xfrm>
-            <a:off x="3169768" y="5166360"/>
+            <a:off x="3169768" y="5221224"/>
             <a:ext cx="1828800" cy="475488"/>
           </a:xfrm>
           <a:prstGeom prst="rect">
@@ -8022,7 +8089,7 @@
         </p:nvSpPr>
         <p:spPr>
           <a:xfrm>
-            <a:off x="3169768" y="5687568"/>
+            <a:off x="3169768" y="5742432"/>
             <a:ext cx="1828800" cy="411480"/>
           </a:xfrm>
           <a:prstGeom prst="rect">

</xml_diff>